<commit_message>
docs(talk-05): add repo and hosted-app links to the closing slide
The close slide now carries two link cards — the GitHub repo and
hollow.wickedways.online, where the shipped campaign runs in the
browser (the wasm build from Part 3, live). Both are real hyperlinks
in the PPTX. The talk's on-ramp section and the closing speaker note
name both links too.

Co-Authored-By: Claude Fable 5 <noreply@anthropic.com>
Claude-Session: https://claude.ai/code/session_01SRYxpKayctQCzwbEeQjjDV
</commit_message>
<xml_diff>
--- a/docs/talks/decks/05-rust-ecosystem.pptx
+++ b/docs/talks/decks/05-rust-ecosystem.pptx
@@ -1222,7 +1222,7 @@
           <a:p>
             <a:r>
               <a:rPr lang="en-US" dirty="0"/>
-              <a:t>Land it: one language, five worlds — browser, desktop, server, editor, bare metal — one codebase, and every tool you saw today is why. The repo is public; everything on this slide is greppable. Thank you — questions.</a:t>
+              <a:t>Land it: one language, five worlds — browser, desktop, server, editor, bare metal — one codebase, and every tool you saw today is why. Two links to leave on screen: the repo is public and everything on this slide is greppable — and the shipped campaign, Hollow House, is playable in the browser right now at hollow.wickedways.online; that is the wasm build from Part 3, live. Thank you — questions.</a:t>
             </a:r>
             <a:endParaRPr lang="en-US" dirty="0"/>
           </a:p>
@@ -7163,14 +7163,41 @@
       </p:sp>
       <p:sp>
         <p:nvSpPr>
-          <p:cNvPr id="6" name="Text 4"/>
-          <p:cNvSpPr/>
-          <p:nvPr/>
-        </p:nvSpPr>
-        <p:spPr>
-          <a:xfrm>
-            <a:off x="548640" y="6172200"/>
-            <a:ext cx="11091672" cy="320040"/>
+          <p:cNvPr id="6" name="Shape 4"/>
+          <p:cNvSpPr/>
+          <p:nvPr/>
+        </p:nvSpPr>
+        <p:spPr>
+          <a:xfrm>
+            <a:off x="2121408" y="5029200"/>
+            <a:ext cx="3703320" cy="868680"/>
+          </a:xfrm>
+          <a:prstGeom prst="roundRect">
+            <a:avLst>
+              <a:gd name="adj" fmla="val 7368"/>
+            </a:avLst>
+          </a:prstGeom>
+          <a:solidFill>
+            <a:srgbClr val="221C31"/>
+          </a:solidFill>
+          <a:ln w="9525">
+            <a:solidFill>
+              <a:srgbClr val="3A3152"/>
+            </a:solidFill>
+            <a:prstDash val="solid"/>
+          </a:ln>
+        </p:spPr>
+      </p:sp>
+      <p:sp>
+        <p:nvSpPr>
+          <p:cNvPr id="7" name="Text 5"/>
+          <p:cNvSpPr/>
+          <p:nvPr/>
+        </p:nvSpPr>
+        <p:spPr>
+          <a:xfrm>
+            <a:off x="2121408" y="5029200"/>
+            <a:ext cx="3703320" cy="868680"/>
           </a:xfrm>
           <a:prstGeom prst="rect">
             <a:avLst/>
@@ -7186,17 +7213,131 @@
               <a:buNone/>
             </a:pPr>
             <a:r>
-              <a:rPr lang="en-US" sz="1200" dirty="0">
-                <a:solidFill>
-                  <a:srgbClr val="9A92A8"/>
+              <a:rPr lang="en-US" sz="1050" b="1" spc="200" kern="0" dirty="0">
+                <a:solidFill>
+                  <a:srgbClr val="C9A227"/>
+                </a:solidFill>
+                <a:latin typeface="Calibri" pitchFamily="34" charset="0"/>
+                <a:ea typeface="Calibri" pitchFamily="34" charset="-122"/>
+                <a:cs typeface="Calibri" pitchFamily="34" charset="-120"/>
+              </a:rPr>
+              <a:t>THE CODE</a:t>
+            </a:r>
+            <a:endParaRPr lang="en-US" sz="1050" dirty="0"/>
+          </a:p>
+          <a:p>
+            <a:pPr algn="ctr" indent="0" marL="0">
+              <a:buNone/>
+            </a:pPr>
+            <a:r>
+              <a:rPr lang="en-US" sz="1150" u="sng" dirty="0">
+                <a:solidFill>
+                  <a:srgbClr val="E9E2D0"/>
                 </a:solidFill>
                 <a:latin typeface="Courier New" pitchFamily="34" charset="0"/>
                 <a:ea typeface="Courier New" pitchFamily="34" charset="-122"/>
                 <a:cs typeface="Courier New" pitchFamily="34" charset="-120"/>
+                <a:hlinkClick r:id="rId1" invalidUrl="" action="" tgtFrame="" tooltip="" history="1" highlightClick="0" endSnd="0">
+                  <a:extLst>
+                    <a:ext uri="{A12FA001-AC4F-418D-AE19-62706E023703}">
+                      <ahyp:hlinkClr xmlns:ahyp="http://schemas.microsoft.com/office/drawing/2018/hyperlinkcolor" val="tx"/>
+                    </a:ext>
+                  </a:extLst>
+                </a:hlinkClick>
               </a:rPr>
               <a:t>github.com/daniel0mullins/WickedWays</a:t>
             </a:r>
-            <a:endParaRPr lang="en-US" sz="1200" dirty="0"/>
+            <a:endParaRPr lang="en-US" sz="1050" dirty="0"/>
+          </a:p>
+        </p:txBody>
+      </p:sp>
+      <p:sp>
+        <p:nvSpPr>
+          <p:cNvPr id="8" name="Shape 6"/>
+          <p:cNvSpPr/>
+          <p:nvPr/>
+        </p:nvSpPr>
+        <p:spPr>
+          <a:xfrm>
+            <a:off x="6373368" y="5029200"/>
+            <a:ext cx="3703320" cy="868680"/>
+          </a:xfrm>
+          <a:prstGeom prst="roundRect">
+            <a:avLst>
+              <a:gd name="adj" fmla="val 7368"/>
+            </a:avLst>
+          </a:prstGeom>
+          <a:solidFill>
+            <a:srgbClr val="221C31"/>
+          </a:solidFill>
+          <a:ln w="9525">
+            <a:solidFill>
+              <a:srgbClr val="3A3152"/>
+            </a:solidFill>
+            <a:prstDash val="solid"/>
+          </a:ln>
+        </p:spPr>
+      </p:sp>
+      <p:sp>
+        <p:nvSpPr>
+          <p:cNvPr id="9" name="Text 7"/>
+          <p:cNvSpPr/>
+          <p:nvPr/>
+        </p:nvSpPr>
+        <p:spPr>
+          <a:xfrm>
+            <a:off x="6373368" y="5029200"/>
+            <a:ext cx="3703320" cy="868680"/>
+          </a:xfrm>
+          <a:prstGeom prst="rect">
+            <a:avLst/>
+          </a:prstGeom>
+          <a:noFill/>
+          <a:ln/>
+        </p:spPr>
+        <p:txBody>
+          <a:bodyPr wrap="square" lIns="0" tIns="0" rIns="0" bIns="0" rtlCol="0" anchor="ctr"/>
+          <a:lstStyle/>
+          <a:p>
+            <a:pPr algn="ctr" indent="0" marL="0">
+              <a:buNone/>
+            </a:pPr>
+            <a:r>
+              <a:rPr lang="en-US" sz="1050" b="1" spc="200" kern="0" dirty="0">
+                <a:solidFill>
+                  <a:srgbClr val="C9A227"/>
+                </a:solidFill>
+                <a:latin typeface="Calibri" pitchFamily="34" charset="0"/>
+                <a:ea typeface="Calibri" pitchFamily="34" charset="-122"/>
+                <a:cs typeface="Calibri" pitchFamily="34" charset="-120"/>
+              </a:rPr>
+              <a:t>PLAY HOLLOW HOUSE</a:t>
+            </a:r>
+            <a:endParaRPr lang="en-US" sz="1050" dirty="0"/>
+          </a:p>
+          <a:p>
+            <a:pPr algn="ctr" indent="0" marL="0">
+              <a:buNone/>
+            </a:pPr>
+            <a:r>
+              <a:rPr lang="en-US" sz="1150" u="sng" dirty="0">
+                <a:solidFill>
+                  <a:srgbClr val="E9E2D0"/>
+                </a:solidFill>
+                <a:latin typeface="Courier New" pitchFamily="34" charset="0"/>
+                <a:ea typeface="Courier New" pitchFamily="34" charset="-122"/>
+                <a:cs typeface="Courier New" pitchFamily="34" charset="-120"/>
+                <a:hlinkClick r:id="rId2" invalidUrl="" action="" tgtFrame="" tooltip="" history="1" highlightClick="0" endSnd="0">
+                  <a:extLst>
+                    <a:ext uri="{A12FA001-AC4F-418D-AE19-62706E023703}">
+                      <ahyp:hlinkClr xmlns:ahyp="http://schemas.microsoft.com/office/drawing/2018/hyperlinkcolor" val="tx"/>
+                    </a:ext>
+                  </a:extLst>
+                </a:hlinkClick>
+              </a:rPr>
+              <a:t>hollow.wickedways.online</a:t>
+            </a:r>
+            <a:endParaRPr lang="en-US" sz="1050" dirty="0"/>
           </a:p>
         </p:txBody>
       </p:sp>

</xml_diff>